<commit_message>
Deploying to gh-pages from @ nlmixr2/nonmem2rx@148faf8772ee64539e65b943306d60534275240b 🚀
</commit_message>
<xml_diff>
--- a/articles/mod-PowerPoint.pptx
+++ b/articles/mod-PowerPoint.pptx
@@ -3682,9 +3682,9 @@
               <a:tblPr/>
               <a:tblGrid>
                 <a:gridCol w="993857"/>
-                <a:gridCol w="749587"/>
-                <a:gridCol w="927350"/>
-                <a:gridCol w="749587"/>
+                <a:gridCol w="660706"/>
+                <a:gridCol w="838468"/>
+                <a:gridCol w="667527"/>
                 <a:gridCol w="2070530"/>
                 <a:gridCol w="975713"/>
                 <a:gridCol w="1141675"/>
@@ -4233,7 +4233,7 @@
                           <a:ea typeface="DejaVu Sans"/>
                           <a:sym typeface="DejaVu Sans"/>
                         </a:rPr>
-                        <a:t>1.370</a:t>
+                        <a:t>1.37</a:t>
                       </a:r>
                     </a:p>
                   </a:txBody>
@@ -4290,7 +4290,7 @@
                           <a:ea typeface="DejaVu Sans"/>
                           <a:sym typeface="DejaVu Sans"/>
                         </a:rPr>
-                        <a:t>0.02979</a:t>
+                        <a:t>0.0298</a:t>
                       </a:r>
                     </a:p>
                   </a:txBody>
@@ -4347,7 +4347,7 @@
                           <a:ea typeface="DejaVu Sans"/>
                           <a:sym typeface="DejaVu Sans"/>
                         </a:rPr>
-                        <a:t>2.174</a:t>
+                        <a:t>2.17</a:t>
                       </a:r>
                     </a:p>
                   </a:txBody>
@@ -4404,7 +4404,7 @@
                           <a:ea typeface="DejaVu Sans"/>
                           <a:sym typeface="DejaVu Sans"/>
                         </a:rPr>
-                        <a:t>3.937 (3.713, 4.173)</a:t>
+                        <a:t>3.94 (3.71, 4.17)</a:t>
                       </a:r>
                     </a:p>
                   </a:txBody>
@@ -4461,7 +4461,7 @@
                           <a:ea typeface="DejaVu Sans"/>
                           <a:sym typeface="DejaVu Sans"/>
                         </a:rPr>
-                        <a:t>32.64</a:t>
+                        <a:t>32.6</a:t>
                       </a:r>
                     </a:p>
                   </a:txBody>
@@ -4518,7 +4518,7 @@
                           <a:ea typeface="DejaVu Sans"/>
                           <a:sym typeface="DejaVu Sans"/>
                         </a:rPr>
-                        <a:t>1.935&lt;</a:t>
+                        <a:t>1.94&lt;</a:t>
                       </a:r>
                     </a:p>
                   </a:txBody>
@@ -4634,7 +4634,7 @@
                           <a:ea typeface="DejaVu Sans"/>
                           <a:sym typeface="DejaVu Sans"/>
                         </a:rPr>
-                        <a:t>4.198</a:t>
+                        <a:t>4.20</a:t>
                       </a:r>
                     </a:p>
                   </a:txBody>
@@ -4691,7 +4691,7 @@
                           <a:ea typeface="DejaVu Sans"/>
                           <a:sym typeface="DejaVu Sans"/>
                         </a:rPr>
-                        <a:t>0.02952</a:t>
+                        <a:t>0.0295</a:t>
                       </a:r>
                     </a:p>
                   </a:txBody>
@@ -4748,7 +4748,7 @@
                           <a:ea typeface="DejaVu Sans"/>
                           <a:sym typeface="DejaVu Sans"/>
                         </a:rPr>
-                        <a:t>0.7032</a:t>
+                        <a:t>0.703</a:t>
                       </a:r>
                     </a:p>
                   </a:txBody>
@@ -4805,7 +4805,7 @@
                           <a:ea typeface="DejaVu Sans"/>
                           <a:sym typeface="DejaVu Sans"/>
                         </a:rPr>
-                        <a:t>66.56 (62.82, 70.53)</a:t>
+                        <a:t>66.6 (62.8, 70.5)</a:t>
                       </a:r>
                     </a:p>
                   </a:txBody>
@@ -4862,7 +4862,7 @@
                           <a:ea typeface="DejaVu Sans"/>
                           <a:sym typeface="DejaVu Sans"/>
                         </a:rPr>
-                        <a:t>32.33</a:t>
+                        <a:t>32.3</a:t>
                       </a:r>
                     </a:p>
                   </a:txBody>
@@ -4919,7 +4919,7 @@
                           <a:ea typeface="DejaVu Sans"/>
                           <a:sym typeface="DejaVu Sans"/>
                         </a:rPr>
-                        <a:t>2.465&lt;</a:t>
+                        <a:t>2.46&lt;</a:t>
                       </a:r>
                     </a:p>
                   </a:txBody>
@@ -5035,7 +5035,7 @@
                           <a:ea typeface="DejaVu Sans"/>
                           <a:sym typeface="DejaVu Sans"/>
                         </a:rPr>
-                        <a:t>1.380</a:t>
+                        <a:t>1.38</a:t>
                       </a:r>
                     </a:p>
                   </a:txBody>
@@ -5092,7 +5092,7 @@
                           <a:ea typeface="DejaVu Sans"/>
                           <a:sym typeface="DejaVu Sans"/>
                         </a:rPr>
-                        <a:t>0.05471</a:t>
+                        <a:t>0.0547</a:t>
                       </a:r>
                     </a:p>
                   </a:txBody>
@@ -5149,7 +5149,7 @@
                           <a:ea typeface="DejaVu Sans"/>
                           <a:sym typeface="DejaVu Sans"/>
                         </a:rPr>
-                        <a:t>3.965</a:t>
+                        <a:t>3.96</a:t>
                       </a:r>
                     </a:p>
                   </a:txBody>
@@ -5206,7 +5206,7 @@
                           <a:ea typeface="DejaVu Sans"/>
                           <a:sym typeface="DejaVu Sans"/>
                         </a:rPr>
-                        <a:t>3.975 (3.571, 4.425)</a:t>
+                        <a:t>3.98 (3.57, 4.42)</a:t>
                       </a:r>
                     </a:p>
                   </a:txBody>
@@ -5263,7 +5263,7 @@
                           <a:ea typeface="DejaVu Sans"/>
                           <a:sym typeface="DejaVu Sans"/>
                         </a:rPr>
-                        <a:t>32.65</a:t>
+                        <a:t>32.7</a:t>
                       </a:r>
                     </a:p>
                   </a:txBody>
@@ -5320,7 +5320,7 @@
                           <a:ea typeface="DejaVu Sans"/>
                           <a:sym typeface="DejaVu Sans"/>
                         </a:rPr>
-                        <a:t>40.50&gt;</a:t>
+                        <a:t>40.5&gt;</a:t>
                       </a:r>
                     </a:p>
                   </a:txBody>
@@ -5436,7 +5436,7 @@
                           <a:ea typeface="DejaVu Sans"/>
                           <a:sym typeface="DejaVu Sans"/>
                         </a:rPr>
-                        <a:t>3.877</a:t>
+                        <a:t>3.88</a:t>
                       </a:r>
                     </a:p>
                   </a:txBody>
@@ -5493,7 +5493,7 @@
                           <a:ea typeface="DejaVu Sans"/>
                           <a:sym typeface="DejaVu Sans"/>
                         </a:rPr>
-                        <a:t>0.03483</a:t>
+                        <a:t>0.0348</a:t>
                       </a:r>
                     </a:p>
                   </a:txBody>
@@ -5550,7 +5550,7 @@
                           <a:ea typeface="DejaVu Sans"/>
                           <a:sym typeface="DejaVu Sans"/>
                         </a:rPr>
-                        <a:t>0.8986</a:t>
+                        <a:t>0.899</a:t>
                       </a:r>
                     </a:p>
                   </a:txBody>
@@ -5607,7 +5607,7 @@
                           <a:ea typeface="DejaVu Sans"/>
                           <a:sym typeface="DejaVu Sans"/>
                         </a:rPr>
-                        <a:t>48.26 (45.07, 51.67)</a:t>
+                        <a:t>48.3 (45.1, 51.7)</a:t>
                       </a:r>
                     </a:p>
                   </a:txBody>
@@ -5664,7 +5664,7 @@
                           <a:ea typeface="DejaVu Sans"/>
                           <a:sym typeface="DejaVu Sans"/>
                         </a:rPr>
-                        <a:t>27.53</a:t>
+                        <a:t>27.5</a:t>
                       </a:r>
                     </a:p>
                   </a:txBody>
@@ -5721,7 +5721,7 @@
                           <a:ea typeface="DejaVu Sans"/>
                           <a:sym typeface="DejaVu Sans"/>
                         </a:rPr>
-                        <a:t>28.37=</a:t>
+                        <a:t>28.4=</a:t>
                       </a:r>
                     </a:p>
                   </a:txBody>
@@ -5841,7 +5841,7 @@
                           <a:ea typeface="DejaVu Sans"/>
                           <a:sym typeface="DejaVu Sans"/>
                         </a:rPr>
-                        <a:t>0.1964</a:t>
+                        <a:t>0.196</a:t>
                       </a:r>
                     </a:p>
                   </a:txBody>
@@ -5902,7 +5902,7 @@
                           <a:ea typeface="DejaVu Sans"/>
                           <a:sym typeface="DejaVu Sans"/>
                         </a:rPr>
-                        <a:t>0.003153</a:t>
+                        <a:t>0.00315</a:t>
                       </a:r>
                     </a:p>
                   </a:txBody>
@@ -5963,7 +5963,7 @@
                           <a:ea typeface="DejaVu Sans"/>
                           <a:sym typeface="DejaVu Sans"/>
                         </a:rPr>
-                        <a:t>1.605</a:t>
+                        <a:t>1.61</a:t>
                       </a:r>
                     </a:p>
                   </a:txBody>
@@ -6024,7 +6024,7 @@
                           <a:ea typeface="DejaVu Sans"/>
                           <a:sym typeface="DejaVu Sans"/>
                         </a:rPr>
-                        <a:t>0.1964 (0.1903, 0.2026)</a:t>
+                        <a:t>0.196 (0.190, 0.203)</a:t>
                       </a:r>
                     </a:p>
                   </a:txBody>

</xml_diff>